<commit_message>
Fix double bullets, overflow, and merged lists in Session 1
</commit_message>
<xml_diff>
--- a/slides/session-01/session-01.pptx
+++ b/slides/session-01/session-01.pptx
@@ -26438,7 +26438,7 @@
         <p:spPr>
           <a:xfrm>
             <a:off x="731520" y="960120"/>
-            <a:ext cx="10515600" cy="365760"/>
+            <a:ext cx="10515600" cy="457200"/>
           </a:xfrm>
           <a:prstGeom prst="rect">
             <a:avLst/>
@@ -26473,7 +26473,7 @@
         </p:nvSpPr>
         <p:spPr>
           <a:xfrm>
-            <a:off x="731520" y="1371600"/>
+            <a:off x="731520" y="1417320"/>
             <a:ext cx="5029200" cy="411480"/>
           </a:xfrm>
           <a:prstGeom prst="rect">
@@ -26509,7 +26509,7 @@
         </p:nvSpPr>
         <p:spPr>
           <a:xfrm>
-            <a:off x="731520" y="1783080"/>
+            <a:off x="731520" y="1828800"/>
             <a:ext cx="5029200" cy="1645920"/>
           </a:xfrm>
           <a:prstGeom prst="rect">
@@ -26554,7 +26554,7 @@
         </p:nvSpPr>
         <p:spPr>
           <a:xfrm>
-            <a:off x="841248" y="1856232"/>
+            <a:off x="841248" y="1901952"/>
             <a:ext cx="4809744" cy="1499616"/>
           </a:xfrm>
           <a:prstGeom prst="rect">
@@ -26580,7 +26580,7 @@
               </a:defRPr>
             </a:pPr>
             <a:r>
-              <a:t>// Operatori: =, &lt;&gt;, &lt;, &gt;, &lt;=, &gt;=</a:t>
+              <a:t>// AND / OR con parentesi:</a:t>
             </a:r>
           </a:p>
           <a:p>
@@ -26612,7 +26612,7 @@
               </a:defRPr>
             </a:pPr>
             <a:r>
-              <a:t>WHERE p.location = "Roma"</a:t>
+              <a:t>WHERE (p.location = "Roma"</a:t>
             </a:r>
           </a:p>
           <a:p>
@@ -26628,7 +26628,7 @@
               </a:defRPr>
             </a:pPr>
             <a:r>
-              <a:t>RETURN p.name, p.title;</a:t>
+              <a:t>   OR  p.location = "Milano")</a:t>
             </a:r>
           </a:p>
           <a:p>
@@ -26643,6 +26643,9 @@
                 <a:latin typeface="Consolas"/>
               </a:defRPr>
             </a:pPr>
+            <a:r>
+              <a:t>  AND p.title CONTAINS "Senior"</a:t>
+            </a:r>
           </a:p>
           <a:p>
             <a:pPr>
@@ -26657,7 +26660,7 @@
               </a:defRPr>
             </a:pPr>
             <a:r>
-              <a:t>// Combinazioni AND / OR con parentesi:</a:t>
+              <a:t>RETURN p.name, p.location, p.title;</a:t>
             </a:r>
           </a:p>
           <a:p>
@@ -26672,6 +26675,35 @@
                 <a:latin typeface="Consolas"/>
               </a:defRPr>
             </a:pPr>
+          </a:p>
+          <a:p>
+            <a:pPr>
+              <a:spcAft>
+                <a:spcPts val="100"/>
+              </a:spcAft>
+              <a:defRPr sz="1000">
+                <a:solidFill>
+                  <a:srgbClr val="7EC68E"/>
+                </a:solidFill>
+                <a:latin typeface="Consolas"/>
+              </a:defRPr>
+            </a:pPr>
+            <a:r>
+              <a:t>// IN per liste:</a:t>
+            </a:r>
+          </a:p>
+          <a:p>
+            <a:pPr>
+              <a:spcAft>
+                <a:spcPts val="100"/>
+              </a:spcAft>
+              <a:defRPr sz="1000">
+                <a:solidFill>
+                  <a:srgbClr val="7EC68E"/>
+                </a:solidFill>
+                <a:latin typeface="Consolas"/>
+              </a:defRPr>
+            </a:pPr>
             <a:r>
               <a:t>MATCH (p:Person)</a:t>
             </a:r>
@@ -26689,7 +26721,7 @@
               </a:defRPr>
             </a:pPr>
             <a:r>
-              <a:t>WHERE (p.location = "Roma"</a:t>
+              <a:t>WHERE p.location IN ("Roma", "Milano")</a:t>
             </a:r>
           </a:p>
           <a:p>
@@ -26705,39 +26737,7 @@
               </a:defRPr>
             </a:pPr>
             <a:r>
-              <a:t>   OR  p.location = "Milano")</a:t>
-            </a:r>
-          </a:p>
-          <a:p>
-            <a:pPr>
-              <a:spcAft>
-                <a:spcPts val="100"/>
-              </a:spcAft>
-              <a:defRPr sz="1000">
-                <a:solidFill>
-                  <a:srgbClr val="7EC68E"/>
-                </a:solidFill>
-                <a:latin typeface="Consolas"/>
-              </a:defRPr>
-            </a:pPr>
-            <a:r>
-              <a:t>  AND p.title CONTAINS "Senior"</a:t>
-            </a:r>
-          </a:p>
-          <a:p>
-            <a:pPr>
-              <a:spcAft>
-                <a:spcPts val="100"/>
-              </a:spcAft>
-              <a:defRPr sz="1000">
-                <a:solidFill>
-                  <a:srgbClr val="7EC68E"/>
-                </a:solidFill>
-                <a:latin typeface="Consolas"/>
-              </a:defRPr>
-            </a:pPr>
-            <a:r>
-              <a:t>RETURN p.name, p.location, p.title;</a:t>
+              <a:t>RETURN p.name, p.location;</a:t>
             </a:r>
           </a:p>
         </p:txBody>
@@ -26750,7 +26750,7 @@
         </p:nvSpPr>
         <p:spPr>
           <a:xfrm>
-            <a:off x="5669280" y="1371600"/>
+            <a:off x="5669280" y="1417320"/>
             <a:ext cx="4846320" cy="411480"/>
           </a:xfrm>
           <a:prstGeom prst="rect">
@@ -26773,7 +26773,7 @@
               </a:defRPr>
             </a:pPr>
             <a:r>
-              <a:t>Ricerca testuale e liste</a:t>
+              <a:t>Testo e valori NULL</a:t>
             </a:r>
           </a:p>
         </p:txBody>
@@ -26786,7 +26786,7 @@
         </p:nvSpPr>
         <p:spPr>
           <a:xfrm>
-            <a:off x="5669280" y="1783080"/>
+            <a:off x="5669280" y="1828800"/>
             <a:ext cx="4846320" cy="1645920"/>
           </a:xfrm>
           <a:prstGeom prst="rect">
@@ -26831,7 +26831,7 @@
         </p:nvSpPr>
         <p:spPr>
           <a:xfrm>
-            <a:off x="5779008" y="1856232"/>
+            <a:off x="5779008" y="1901952"/>
             <a:ext cx="4626864" cy="1499616"/>
           </a:xfrm>
           <a:prstGeom prst="rect">
@@ -26857,7 +26857,7 @@
               </a:defRPr>
             </a:pPr>
             <a:r>
-              <a:t>// CONTAINS, STARTS WITH, ENDS WITH</a:t>
+              <a:t>// CONTAINS, STARTS WITH, ENDS WITH:</a:t>
             </a:r>
           </a:p>
           <a:p>
@@ -26905,7 +26905,7 @@
               </a:defRPr>
             </a:pPr>
             <a:r>
-              <a:t>RETURN s.name;  // Python, PySpark</a:t>
+              <a:t>RETURN s.name UNION</a:t>
             </a:r>
           </a:p>
           <a:p>
@@ -26920,6 +26920,9 @@
                 <a:latin typeface="Consolas"/>
               </a:defRPr>
             </a:pPr>
+            <a:r>
+              <a:t>MATCH (s:Skill)</a:t>
+            </a:r>
           </a:p>
           <a:p>
             <a:pPr>
@@ -26934,7 +26937,7 @@
               </a:defRPr>
             </a:pPr>
             <a:r>
-              <a:t>// IN per liste:</a:t>
+              <a:t>WHERE s.name CONTAINS "cloud"</a:t>
             </a:r>
           </a:p>
           <a:p>
@@ -26950,6 +26953,51 @@
               </a:defRPr>
             </a:pPr>
             <a:r>
+              <a:t>RETURN s.name;</a:t>
+            </a:r>
+          </a:p>
+          <a:p>
+            <a:pPr>
+              <a:spcAft>
+                <a:spcPts val="100"/>
+              </a:spcAft>
+              <a:defRPr sz="1000">
+                <a:solidFill>
+                  <a:srgbClr val="7EC68E"/>
+                </a:solidFill>
+                <a:latin typeface="Consolas"/>
+              </a:defRPr>
+            </a:pPr>
+          </a:p>
+          <a:p>
+            <a:pPr>
+              <a:spcAft>
+                <a:spcPts val="100"/>
+              </a:spcAft>
+              <a:defRPr sz="1000">
+                <a:solidFill>
+                  <a:srgbClr val="7EC68E"/>
+                </a:solidFill>
+                <a:latin typeface="Consolas"/>
+              </a:defRPr>
+            </a:pPr>
+            <a:r>
+              <a:t>// IS NULL / IS NOT NULL:</a:t>
+            </a:r>
+          </a:p>
+          <a:p>
+            <a:pPr>
+              <a:spcAft>
+                <a:spcPts val="100"/>
+              </a:spcAft>
+              <a:defRPr sz="1000">
+                <a:solidFill>
+                  <a:srgbClr val="7EC68E"/>
+                </a:solidFill>
+                <a:latin typeface="Consolas"/>
+              </a:defRPr>
+            </a:pPr>
+            <a:r>
               <a:t>MATCH (p:Person)</a:t>
             </a:r>
           </a:p>
@@ -26966,7 +27014,7 @@
               </a:defRPr>
             </a:pPr>
             <a:r>
-              <a:t>WHERE p.location IN ("Roma", "Milano")</a:t>
+              <a:t>WHERE p.location IS NULL</a:t>
             </a:r>
           </a:p>
           <a:p>
@@ -26982,84 +27030,7 @@
               </a:defRPr>
             </a:pPr>
             <a:r>
-              <a:t>RETURN p.name, p.location;</a:t>
-            </a:r>
-          </a:p>
-          <a:p>
-            <a:pPr>
-              <a:spcAft>
-                <a:spcPts val="100"/>
-              </a:spcAft>
-              <a:defRPr sz="1000">
-                <a:solidFill>
-                  <a:srgbClr val="7EC68E"/>
-                </a:solidFill>
-                <a:latin typeface="Consolas"/>
-              </a:defRPr>
-            </a:pPr>
-          </a:p>
-          <a:p>
-            <a:pPr>
-              <a:spcAft>
-                <a:spcPts val="100"/>
-              </a:spcAft>
-              <a:defRPr sz="1000">
-                <a:solidFill>
-                  <a:srgbClr val="7EC68E"/>
-                </a:solidFill>
-                <a:latin typeface="Consolas"/>
-              </a:defRPr>
-            </a:pPr>
-            <a:r>
-              <a:t>// IS NULL / IS NOT NULL:</a:t>
-            </a:r>
-          </a:p>
-          <a:p>
-            <a:pPr>
-              <a:spcAft>
-                <a:spcPts val="100"/>
-              </a:spcAft>
-              <a:defRPr sz="1000">
-                <a:solidFill>
-                  <a:srgbClr val="7EC68E"/>
-                </a:solidFill>
-                <a:latin typeface="Consolas"/>
-              </a:defRPr>
-            </a:pPr>
-            <a:r>
-              <a:t>MATCH (p:Person)</a:t>
-            </a:r>
-          </a:p>
-          <a:p>
-            <a:pPr>
-              <a:spcAft>
-                <a:spcPts val="100"/>
-              </a:spcAft>
-              <a:defRPr sz="1000">
-                <a:solidFill>
-                  <a:srgbClr val="7EC68E"/>
-                </a:solidFill>
-                <a:latin typeface="Consolas"/>
-              </a:defRPr>
-            </a:pPr>
-            <a:r>
-              <a:t>WHERE p.location IS NULL</a:t>
-            </a:r>
-          </a:p>
-          <a:p>
-            <a:pPr>
-              <a:spcAft>
-                <a:spcPts val="100"/>
-              </a:spcAft>
-              <a:defRPr sz="1000">
-                <a:solidFill>
-                  <a:srgbClr val="7EC68E"/>
-                </a:solidFill>
-                <a:latin typeface="Consolas"/>
-              </a:defRPr>
-            </a:pPr>
-            <a:r>
-              <a:t>RETURN p.name;  // location mancante</a:t>
+              <a:t>RETURN p.name;</a:t>
             </a:r>
           </a:p>
         </p:txBody>
@@ -27072,7 +27043,7 @@
         </p:nvSpPr>
         <p:spPr>
           <a:xfrm>
-            <a:off x="731520" y="3749039"/>
+            <a:off x="731520" y="3840480"/>
             <a:ext cx="10698480" cy="36576"/>
           </a:xfrm>
           <a:prstGeom prst="rect">
@@ -27115,7 +27086,7 @@
         </p:nvSpPr>
         <p:spPr>
           <a:xfrm>
-            <a:off x="731520" y="3931920"/>
+            <a:off x="731520" y="4023360"/>
             <a:ext cx="10515600" cy="365760"/>
           </a:xfrm>
           <a:prstGeom prst="rect">
@@ -27151,8 +27122,8 @@
         </p:nvSpPr>
         <p:spPr>
           <a:xfrm>
-            <a:off x="731520" y="4343400"/>
-            <a:ext cx="5029200" cy="1554480"/>
+            <a:off x="731520" y="4434840"/>
+            <a:ext cx="10515600" cy="1645920"/>
           </a:xfrm>
           <a:prstGeom prst="rect">
             <a:avLst/>
@@ -27196,8 +27167,8 @@
         </p:nvSpPr>
         <p:spPr>
           <a:xfrm>
-            <a:off x="841248" y="4416552"/>
-            <a:ext cx="4809744" cy="1408176"/>
+            <a:off x="841248" y="4507992"/>
+            <a:ext cx="10296144" cy="1499616"/>
           </a:xfrm>
           <a:prstGeom prst="rect">
             <a:avLst/>
@@ -27222,7 +27193,7 @@
               </a:defRPr>
             </a:pPr>
             <a:r>
-              <a:t>// ORDER BY (ASC default, DESC esplicito)</a:t>
+              <a:t>MATCH (p:Person)</a:t>
             </a:r>
           </a:p>
           <a:p>
@@ -27238,7 +27209,7 @@
               </a:defRPr>
             </a:pPr>
             <a:r>
-              <a:t>MATCH (p:Person)</a:t>
+              <a:t>RETURN p.name, p.location AS nome, p.title AS ruolo</a:t>
             </a:r>
           </a:p>
           <a:p>
@@ -27254,7 +27225,7 @@
               </a:defRPr>
             </a:pPr>
             <a:r>
-              <a:t>RETURN p.name, p.title</a:t>
+              <a:t>ORDER BY nome ASC</a:t>
             </a:r>
           </a:p>
           <a:p>
@@ -27270,7 +27241,7 @@
               </a:defRPr>
             </a:pPr>
             <a:r>
-              <a:t>ORDER BY p.name ASC, p.title DESC;</a:t>
+              <a:t>SKIP 10 LIMIT 10;  // pagina 2</a:t>
             </a:r>
           </a:p>
           <a:p>
@@ -27299,7 +27270,7 @@
               </a:defRPr>
             </a:pPr>
             <a:r>
-              <a:t>// LIMIT + SKIP per paginazione:</a:t>
+              <a:t>MATCH (p:Person)-[:WORKED_ON]-&gt;(proj:Project)</a:t>
             </a:r>
           </a:p>
           <a:p>
@@ -27315,7 +27286,7 @@
               </a:defRPr>
             </a:pPr>
             <a:r>
-              <a:t>MATCH (p:Person)</a:t>
+              <a:t>RETURN DISTINCT p.location AS sedi</a:t>
             </a:r>
           </a:p>
           <a:p>
@@ -27331,280 +27302,7 @@
               </a:defRPr>
             </a:pPr>
             <a:r>
-              <a:t>RETURN p.name</a:t>
-            </a:r>
-          </a:p>
-          <a:p>
-            <a:pPr>
-              <a:spcAft>
-                <a:spcPts val="100"/>
-              </a:spcAft>
-              <a:defRPr sz="1000">
-                <a:solidFill>
-                  <a:srgbClr val="7EC68E"/>
-                </a:solidFill>
-                <a:latin typeface="Consolas"/>
-              </a:defRPr>
-            </a:pPr>
-            <a:r>
-              <a:t>ORDER BY p.name</a:t>
-            </a:r>
-          </a:p>
-          <a:p>
-            <a:pPr>
-              <a:spcAft>
-                <a:spcPts val="100"/>
-              </a:spcAft>
-              <a:defRPr sz="1000">
-                <a:solidFill>
-                  <a:srgbClr val="7EC68E"/>
-                </a:solidFill>
-                <a:latin typeface="Consolas"/>
-              </a:defRPr>
-            </a:pPr>
-            <a:r>
-              <a:t>SKIP 10 LIMIT 10;  // pagina 2</a:t>
-            </a:r>
-          </a:p>
-        </p:txBody>
-      </p:sp>
-      <p:sp>
-        <p:nvSpPr>
-          <p:cNvPr id="14" name="Rectangle 13"/>
-          <p:cNvSpPr/>
-          <p:nvPr/>
-        </p:nvSpPr>
-        <p:spPr>
-          <a:xfrm>
-            <a:off x="5669280" y="4343400"/>
-            <a:ext cx="4846320" cy="1828800"/>
-          </a:xfrm>
-          <a:prstGeom prst="rect">
-            <a:avLst/>
-          </a:prstGeom>
-          <a:solidFill>
-            <a:srgbClr val="1B2A4A"/>
-          </a:solidFill>
-          <a:ln w="12700">
-            <a:solidFill>
-              <a:srgbClr val="2D4F7A"/>
-            </a:solidFill>
-          </a:ln>
-        </p:spPr>
-        <p:style>
-          <a:lnRef idx="1">
-            <a:schemeClr val="accent1"/>
-          </a:lnRef>
-          <a:fillRef idx="3">
-            <a:schemeClr val="accent1"/>
-          </a:fillRef>
-          <a:effectRef idx="2">
-            <a:schemeClr val="accent1"/>
-          </a:effectRef>
-          <a:fontRef idx="minor">
-            <a:schemeClr val="lt1"/>
-          </a:fontRef>
-        </p:style>
-        <p:txBody>
-          <a:bodyPr rtlCol="0" anchor="ctr"/>
-          <a:lstStyle/>
-          <a:p>
-            <a:pPr algn="ctr"/>
-          </a:p>
-        </p:txBody>
-      </p:sp>
-      <p:sp>
-        <p:nvSpPr>
-          <p:cNvPr id="15" name="TextBox 14"/>
-          <p:cNvSpPr txBox="1"/>
-          <p:nvPr/>
-        </p:nvSpPr>
-        <p:spPr>
-          <a:xfrm>
-            <a:off x="5779008" y="4416552"/>
-            <a:ext cx="4626864" cy="1682496"/>
-          </a:xfrm>
-          <a:prstGeom prst="rect">
-            <a:avLst/>
-          </a:prstGeom>
-          <a:noFill/>
-        </p:spPr>
-        <p:txBody>
-          <a:bodyPr wrap="square">
-            <a:spAutoFit/>
-          </a:bodyPr>
-          <a:lstStyle/>
-          <a:p>
-            <a:pPr>
-              <a:spcAft>
-                <a:spcPts val="100"/>
-              </a:spcAft>
-              <a:defRPr sz="1000">
-                <a:solidFill>
-                  <a:srgbClr val="7EC68E"/>
-                </a:solidFill>
-                <a:latin typeface="Consolas"/>
-              </a:defRPr>
-            </a:pPr>
-            <a:r>
-              <a:t>// DISTINCT per rimuovere duplicati:</a:t>
-            </a:r>
-          </a:p>
-          <a:p>
-            <a:pPr>
-              <a:spcAft>
-                <a:spcPts val="100"/>
-              </a:spcAft>
-              <a:defRPr sz="1000">
-                <a:solidFill>
-                  <a:srgbClr val="7EC68E"/>
-                </a:solidFill>
-                <a:latin typeface="Consolas"/>
-              </a:defRPr>
-            </a:pPr>
-            <a:r>
-              <a:t>MATCH (p:Person)-[:WORKED_ON]-&gt;(proj:Project)</a:t>
-            </a:r>
-          </a:p>
-          <a:p>
-            <a:pPr>
-              <a:spcAft>
-                <a:spcPts val="100"/>
-              </a:spcAft>
-              <a:defRPr sz="1000">
-                <a:solidFill>
-                  <a:srgbClr val="7EC68E"/>
-                </a:solidFill>
-                <a:latin typeface="Consolas"/>
-              </a:defRPr>
-            </a:pPr>
-            <a:r>
-              <a:t>RETURN DISTINCT p.location AS sedi</a:t>
-            </a:r>
-          </a:p>
-          <a:p>
-            <a:pPr>
-              <a:spcAft>
-                <a:spcPts val="100"/>
-              </a:spcAft>
-              <a:defRPr sz="1000">
-                <a:solidFill>
-                  <a:srgbClr val="7EC68E"/>
-                </a:solidFill>
-                <a:latin typeface="Consolas"/>
-              </a:defRPr>
-            </a:pPr>
-            <a:r>
               <a:t>ORDER BY sedi;</a:t>
-            </a:r>
-          </a:p>
-          <a:p>
-            <a:pPr>
-              <a:spcAft>
-                <a:spcPts val="100"/>
-              </a:spcAft>
-              <a:defRPr sz="1000">
-                <a:solidFill>
-                  <a:srgbClr val="7EC68E"/>
-                </a:solidFill>
-                <a:latin typeface="Consolas"/>
-              </a:defRPr>
-            </a:pPr>
-          </a:p>
-          <a:p>
-            <a:pPr>
-              <a:spcAft>
-                <a:spcPts val="100"/>
-              </a:spcAft>
-              <a:defRPr sz="1000">
-                <a:solidFill>
-                  <a:srgbClr val="7EC68E"/>
-                </a:solidFill>
-                <a:latin typeface="Consolas"/>
-              </a:defRPr>
-            </a:pPr>
-            <a:r>
-              <a:t>// AS per rinominare colonne:</a:t>
-            </a:r>
-          </a:p>
-          <a:p>
-            <a:pPr>
-              <a:spcAft>
-                <a:spcPts val="100"/>
-              </a:spcAft>
-              <a:defRPr sz="1000">
-                <a:solidFill>
-                  <a:srgbClr val="7EC68E"/>
-                </a:solidFill>
-                <a:latin typeface="Consolas"/>
-              </a:defRPr>
-            </a:pPr>
-            <a:r>
-              <a:t>MATCH (p:Person)</a:t>
-            </a:r>
-          </a:p>
-          <a:p>
-            <a:pPr>
-              <a:spcAft>
-                <a:spcPts val="100"/>
-              </a:spcAft>
-              <a:defRPr sz="1000">
-                <a:solidFill>
-                  <a:srgbClr val="7EC68E"/>
-                </a:solidFill>
-                <a:latin typeface="Consolas"/>
-              </a:defRPr>
-            </a:pPr>
-            <a:r>
-              <a:t>RETURN p.name AS nome,</a:t>
-            </a:r>
-          </a:p>
-          <a:p>
-            <a:pPr>
-              <a:spcAft>
-                <a:spcPts val="100"/>
-              </a:spcAft>
-              <a:defRPr sz="1000">
-                <a:solidFill>
-                  <a:srgbClr val="7EC68E"/>
-                </a:solidFill>
-                <a:latin typeface="Consolas"/>
-              </a:defRPr>
-            </a:pPr>
-            <a:r>
-              <a:t>       p.title AS ruolo,</a:t>
-            </a:r>
-          </a:p>
-          <a:p>
-            <a:pPr>
-              <a:spcAft>
-                <a:spcPts val="100"/>
-              </a:spcAft>
-              <a:defRPr sz="1000">
-                <a:solidFill>
-                  <a:srgbClr val="7EC68E"/>
-                </a:solidFill>
-                <a:latin typeface="Consolas"/>
-              </a:defRPr>
-            </a:pPr>
-            <a:r>
-              <a:t>       p.location AS sede</a:t>
-            </a:r>
-          </a:p>
-          <a:p>
-            <a:pPr>
-              <a:spcAft>
-                <a:spcPts val="100"/>
-              </a:spcAft>
-              <a:defRPr sz="1000">
-                <a:solidFill>
-                  <a:srgbClr val="7EC68E"/>
-                </a:solidFill>
-                <a:latin typeface="Consolas"/>
-              </a:defRPr>
-            </a:pPr>
-            <a:r>
-              <a:t>ORDER BY nome;</a:t>
             </a:r>
           </a:p>
         </p:txBody>
@@ -29076,7 +28774,7 @@
               </a:defRPr>
             </a:pPr>
             <a:r>
-              <a:t>•    Crea automaticamente un indice RANGE</a:t>
+              <a:t>  Crea automaticamente un indice RANGE</a:t>
             </a:r>
           </a:p>
           <a:p>
@@ -29092,7 +28790,7 @@
               </a:defRPr>
             </a:pPr>
             <a:r>
-              <a:t>•    Rilevante per MERGE: senza constraint, MERGE concorrente può duplicare</a:t>
+              <a:t>  Rilevante per MERGE: senza constraint, MERGE concorrente può duplicare</a:t>
             </a:r>
           </a:p>
           <a:p>
@@ -30625,7 +30323,7 @@
               </a:defRPr>
             </a:pPr>
             <a:r>
-              <a:t>// Poi filtra una per una in memoria</a:t>
+              <a:t>//  Poi filtra una per una in memoria</a:t>
             </a:r>
           </a:p>
           <a:p>
@@ -30671,22 +30369,6 @@
             </a:pPr>
             <a:r>
               <a:t>// dbHits: ~3 (indice + recupero nodo)</a:t>
-            </a:r>
-          </a:p>
-          <a:p>
-            <a:pPr>
-              <a:spcAft>
-                <a:spcPts val="100"/>
-              </a:spcAft>
-              <a:defRPr sz="1000">
-                <a:solidFill>
-                  <a:srgbClr val="7EC68E"/>
-                </a:solidFill>
-                <a:latin typeface="Consolas"/>
-              </a:defRPr>
-            </a:pPr>
-            <a:r>
-              <a:t>// Solo i nodi corrispondenti</a:t>
             </a:r>
           </a:p>
           <a:p>
@@ -30884,7 +30566,7 @@
               </a:defRPr>
             </a:pPr>
             <a:r>
-              <a:t>•    Costo: latenza di rete N volte + N transazioni</a:t>
+              <a:t>  Costo: latenza di rete N volte + N transazioni</a:t>
             </a:r>
           </a:p>
           <a:p>
@@ -30916,7 +30598,7 @@
               </a:defRPr>
             </a:pPr>
             <a:r>
-              <a:t>•    Costo: 1 chiamata + 1 transazione + ciclo nel database</a:t>
+              <a:t>  Costo: 1 chiamata + 1 transazione + ciclo nel database</a:t>
             </a:r>
           </a:p>
           <a:p>
@@ -31520,7 +31202,7 @@
               </a:defRPr>
             </a:pPr>
             <a:r>
-              <a:t>•    • :play movie-graph per tutorial interattivo</a:t>
+              <a:t>  • :play movie-graph per tutorial interattivo</a:t>
             </a:r>
           </a:p>
           <a:p>
@@ -31536,7 +31218,7 @@
               </a:defRPr>
             </a:pPr>
             <a:r>
-              <a:t>•    • Visualizzazione grafica a cerchi e frecce</a:t>
+              <a:t>  • Visualizzazione grafica a cerchi e frecce</a:t>
             </a:r>
           </a:p>
           <a:p>
@@ -31552,7 +31234,7 @@
               </a:defRPr>
             </a:pPr>
             <a:r>
-              <a:t>•    • Esportazione PNG, CSV, JSON</a:t>
+              <a:t>  • Esportazione PNG, CSV, JSON</a:t>
             </a:r>
           </a:p>
           <a:p>
@@ -31584,7 +31266,7 @@
               </a:defRPr>
             </a:pPr>
             <a:r>
-              <a:t>•    • Ricerca in linguaggio naturale</a:t>
+              <a:t>  • Ricerca in linguaggio naturale</a:t>
             </a:r>
           </a:p>
           <a:p>
@@ -31600,7 +31282,7 @@
               </a:defRPr>
             </a:pPr>
             <a:r>
-              <a:t>•    • Grafi animati, filtri visuali</a:t>
+              <a:t>  • Grafi animati, filtri visuali</a:t>
             </a:r>
           </a:p>
           <a:p>
@@ -33518,7 +33200,7 @@
               </a:defRPr>
             </a:pPr>
             <a:r>
-              <a:t>•    • HAS_SKILL {proficiency: 1-5}</a:t>
+              <a:t>  • HAS_SKILL {proficiency: 1-5}</a:t>
             </a:r>
           </a:p>
           <a:p>
@@ -33534,7 +33216,7 @@
               </a:defRPr>
             </a:pPr>
             <a:r>
-              <a:t>•    • WORKED_ON {role: Developer/Architect/etc.}</a:t>
+              <a:t>  • WORKED_ON {role: Developer/Architect/etc.}</a:t>
             </a:r>
           </a:p>
           <a:p>
@@ -33550,7 +33232,7 @@
               </a:defRPr>
             </a:pPr>
             <a:r>
-              <a:t>•    • REPORTS_TO (Person → Supervisor)</a:t>
+              <a:t>  • REPORTS_TO (Person → Supervisor)</a:t>
             </a:r>
           </a:p>
           <a:p>
@@ -33849,7 +33531,7 @@
         <p:spPr>
           <a:xfrm>
             <a:off x="731520" y="1371600"/>
-            <a:ext cx="3200400" cy="365760"/>
+            <a:ext cx="5029200" cy="365760"/>
           </a:xfrm>
           <a:prstGeom prst="rect">
             <a:avLst/>
@@ -33885,7 +33567,7 @@
         <p:spPr>
           <a:xfrm>
             <a:off x="731520" y="1783080"/>
-            <a:ext cx="2286000" cy="1097280"/>
+            <a:ext cx="5029200" cy="731520"/>
           </a:xfrm>
           <a:prstGeom prst="rect">
             <a:avLst/>
@@ -33899,130 +33581,15 @@
           <a:lstStyle/>
           <a:p>
             <a:pPr algn="l">
-              <a:spcAft>
-                <a:spcPts val="0"/>
-              </a:spcAft>
-              <a:defRPr sz="1000">
+              <a:defRPr sz="1100" b="0">
                 <a:solidFill>
                   <a:srgbClr val="7EC68E"/>
                 </a:solidFill>
-                <a:latin typeface="Calibri"/>
-              </a:defRPr>
-            </a:pPr>
-            <a:r>
-              <a:t>•  employee_id</a:t>
-            </a:r>
-          </a:p>
-          <a:p>
-            <a:pPr algn="l">
-              <a:spcAft>
-                <a:spcPts val="0"/>
-              </a:spcAft>
-              <a:defRPr sz="1000">
-                <a:solidFill>
-                  <a:srgbClr val="7EC68E"/>
-                </a:solidFill>
-                <a:latin typeface="Calibri"/>
-              </a:defRPr>
-            </a:pPr>
-            <a:r>
-              <a:t>•  name</a:t>
-            </a:r>
-          </a:p>
-          <a:p>
-            <a:pPr algn="l">
-              <a:spcAft>
-                <a:spcPts val="0"/>
-              </a:spcAft>
-              <a:defRPr sz="1000">
-                <a:solidFill>
-                  <a:srgbClr val="7EC68E"/>
-                </a:solidFill>
-                <a:latin typeface="Calibri"/>
-              </a:defRPr>
-            </a:pPr>
-            <a:r>
-              <a:t>•  gender</a:t>
-            </a:r>
-          </a:p>
-          <a:p>
-            <a:pPr algn="l">
-              <a:spcAft>
-                <a:spcPts val="0"/>
-              </a:spcAft>
-              <a:defRPr sz="1000">
-                <a:solidFill>
-                  <a:srgbClr val="7EC68E"/>
-                </a:solidFill>
-                <a:latin typeface="Calibri"/>
-              </a:defRPr>
-            </a:pPr>
-            <a:r>
-              <a:t>•  discipline</a:t>
-            </a:r>
-          </a:p>
-          <a:p>
-            <a:pPr algn="l">
-              <a:spcAft>
-                <a:spcPts val="0"/>
-              </a:spcAft>
-              <a:defRPr sz="1000">
-                <a:solidFill>
-                  <a:srgbClr val="7EC68E"/>
-                </a:solidFill>
-                <a:latin typeface="Calibri"/>
-              </a:defRPr>
-            </a:pPr>
-            <a:r>
-              <a:t>•  department</a:t>
-            </a:r>
-          </a:p>
-          <a:p>
-            <a:pPr algn="l">
-              <a:spcAft>
-                <a:spcPts val="0"/>
-              </a:spcAft>
-              <a:defRPr sz="1000">
-                <a:solidFill>
-                  <a:srgbClr val="7EC68E"/>
-                </a:solidFill>
-                <a:latin typeface="Calibri"/>
-              </a:defRPr>
-            </a:pPr>
-            <a:r>
-              <a:t>•  code</a:t>
-            </a:r>
-          </a:p>
-          <a:p>
-            <a:pPr algn="l">
-              <a:spcAft>
-                <a:spcPts val="0"/>
-              </a:spcAft>
-              <a:defRPr sz="1000">
-                <a:solidFill>
-                  <a:srgbClr val="7EC68E"/>
-                </a:solidFill>
-                <a:latin typeface="Calibri"/>
-              </a:defRPr>
-            </a:pPr>
-            <a:r>
-              <a:t>•  location</a:t>
-            </a:r>
-          </a:p>
-          <a:p>
-            <a:pPr algn="l">
-              <a:spcAft>
-                <a:spcPts val="0"/>
-              </a:spcAft>
-              <a:defRPr sz="1000">
-                <a:solidFill>
-                  <a:srgbClr val="7EC68E"/>
-                </a:solidFill>
-                <a:latin typeface="Calibri"/>
-              </a:defRPr>
-            </a:pPr>
-            <a:r>
-              <a:t>•  title</a:t>
+                <a:latin typeface="Consolas"/>
+              </a:defRPr>
+            </a:pPr>
+            <a:r>
+              <a:t>employee_id  name  gender  discipline</a:t>
             </a:r>
           </a:p>
         </p:txBody>
@@ -34035,8 +33602,8 @@
         </p:nvSpPr>
         <p:spPr>
           <a:xfrm>
-            <a:off x="3840480" y="1371600"/>
-            <a:ext cx="3200400" cy="365760"/>
+            <a:off x="731520" y="2103120"/>
+            <a:ext cx="5029200" cy="731520"/>
           </a:xfrm>
           <a:prstGeom prst="rect">
             <a:avLst/>
@@ -34050,15 +33617,15 @@
           <a:lstStyle/>
           <a:p>
             <a:pPr algn="l">
-              <a:defRPr sz="1600" b="1">
-                <a:solidFill>
-                  <a:srgbClr val="F08040"/>
-                </a:solidFill>
-                <a:latin typeface="Calibri"/>
-              </a:defRPr>
-            </a:pPr>
-            <a:r>
-              <a:t>(:Skill)</a:t>
+              <a:defRPr sz="1100" b="0">
+                <a:solidFill>
+                  <a:srgbClr val="7EC68E"/>
+                </a:solidFill>
+                <a:latin typeface="Consolas"/>
+              </a:defRPr>
+            </a:pPr>
+            <a:r>
+              <a:t>department  code  location  title       </a:t>
             </a:r>
           </a:p>
         </p:txBody>
@@ -34071,8 +33638,8 @@
         </p:nvSpPr>
         <p:spPr>
           <a:xfrm>
-            <a:off x="3840480" y="1783080"/>
-            <a:ext cx="2286000" cy="1097280"/>
+            <a:off x="5669280" y="1371600"/>
+            <a:ext cx="5029200" cy="365760"/>
           </a:xfrm>
           <a:prstGeom prst="rect">
             <a:avLst/>
@@ -34086,34 +33653,15 @@
           <a:lstStyle/>
           <a:p>
             <a:pPr algn="l">
-              <a:spcAft>
-                <a:spcPts val="0"/>
-              </a:spcAft>
-              <a:defRPr sz="1000">
-                <a:solidFill>
-                  <a:srgbClr val="7EC68E"/>
+              <a:defRPr sz="1600" b="1">
+                <a:solidFill>
+                  <a:srgbClr val="F08040"/>
                 </a:solidFill>
                 <a:latin typeface="Calibri"/>
               </a:defRPr>
             </a:pPr>
             <a:r>
-              <a:t>•  name</a:t>
-            </a:r>
-          </a:p>
-          <a:p>
-            <a:pPr algn="l">
-              <a:spcAft>
-                <a:spcPts val="0"/>
-              </a:spcAft>
-              <a:defRPr sz="1000">
-                <a:solidFill>
-                  <a:srgbClr val="7EC68E"/>
-                </a:solidFill>
-                <a:latin typeface="Calibri"/>
-              </a:defRPr>
-            </a:pPr>
-            <a:r>
-              <a:t>•  </a:t>
+              <a:t>(:Skill)  e  (:Project)  e  (:Supervisor)</a:t>
             </a:r>
           </a:p>
         </p:txBody>
@@ -34126,8 +33674,8 @@
         </p:nvSpPr>
         <p:spPr>
           <a:xfrm>
-            <a:off x="5943600" y="1371600"/>
-            <a:ext cx="3200400" cy="365760"/>
+            <a:off x="5669280" y="1783080"/>
+            <a:ext cx="5029200" cy="731520"/>
           </a:xfrm>
           <a:prstGeom prst="rect">
             <a:avLst/>
@@ -34141,15 +33689,15 @@
           <a:lstStyle/>
           <a:p>
             <a:pPr algn="l">
-              <a:defRPr sz="1600" b="1">
-                <a:solidFill>
-                  <a:srgbClr val="F08040"/>
-                </a:solidFill>
-                <a:latin typeface="Calibri"/>
-              </a:defRPr>
-            </a:pPr>
-            <a:r>
-              <a:t>(:Project)</a:t>
+              <a:defRPr sz="1100" b="0">
+                <a:solidFill>
+                  <a:srgbClr val="7EC68E"/>
+                </a:solidFill>
+                <a:latin typeface="Consolas"/>
+              </a:defRPr>
+            </a:pPr>
+            <a:r>
+              <a:t>Skill: name</a:t>
             </a:r>
           </a:p>
         </p:txBody>
@@ -34162,8 +33710,8 @@
         </p:nvSpPr>
         <p:spPr>
           <a:xfrm>
-            <a:off x="5943600" y="1783080"/>
-            <a:ext cx="2286000" cy="1097280"/>
+            <a:off x="5669280" y="2103120"/>
+            <a:ext cx="5029200" cy="731520"/>
           </a:xfrm>
           <a:prstGeom prst="rect">
             <a:avLst/>
@@ -34177,34 +33725,15 @@
           <a:lstStyle/>
           <a:p>
             <a:pPr algn="l">
-              <a:spcAft>
-                <a:spcPts val="0"/>
-              </a:spcAft>
-              <a:defRPr sz="1000">
+              <a:defRPr sz="1100" b="0">
                 <a:solidFill>
                   <a:srgbClr val="7EC68E"/>
                 </a:solidFill>
-                <a:latin typeface="Calibri"/>
-              </a:defRPr>
-            </a:pPr>
-            <a:r>
-              <a:t>•  project_id</a:t>
-            </a:r>
-          </a:p>
-          <a:p>
-            <a:pPr algn="l">
-              <a:spcAft>
-                <a:spcPts val="0"/>
-              </a:spcAft>
-              <a:defRPr sz="1000">
-                <a:solidFill>
-                  <a:srgbClr val="7EC68E"/>
-                </a:solidFill>
-                <a:latin typeface="Calibri"/>
-              </a:defRPr>
-            </a:pPr>
-            <a:r>
-              <a:t>•  name</a:t>
+                <a:latin typeface="Consolas"/>
+              </a:defRPr>
+            </a:pPr>
+            <a:r>
+              <a:t>Project: project_id, name</a:t>
             </a:r>
           </a:p>
         </p:txBody>
@@ -34217,8 +33746,8 @@
         </p:nvSpPr>
         <p:spPr>
           <a:xfrm>
-            <a:off x="7772400" y="1371600"/>
-            <a:ext cx="3200400" cy="365760"/>
+            <a:off x="5669280" y="2423160"/>
+            <a:ext cx="5029200" cy="731520"/>
           </a:xfrm>
           <a:prstGeom prst="rect">
             <a:avLst/>
@@ -34232,77 +33761,22 @@
           <a:lstStyle/>
           <a:p>
             <a:pPr algn="l">
-              <a:defRPr sz="1600" b="1">
-                <a:solidFill>
-                  <a:srgbClr val="F08040"/>
-                </a:solidFill>
-                <a:latin typeface="Calibri"/>
-              </a:defRPr>
-            </a:pPr>
-            <a:r>
-              <a:t>(:Supervisor)</a:t>
+              <a:defRPr sz="1100" b="0">
+                <a:solidFill>
+                  <a:srgbClr val="7EC68E"/>
+                </a:solidFill>
+                <a:latin typeface="Consolas"/>
+              </a:defRPr>
+            </a:pPr>
+            <a:r>
+              <a:t>Supervisor: supervisor_id, name</a:t>
             </a:r>
           </a:p>
         </p:txBody>
       </p:sp>
       <p:sp>
         <p:nvSpPr>
-          <p:cNvPr id="11" name="TextBox 10"/>
-          <p:cNvSpPr txBox="1"/>
-          <p:nvPr/>
-        </p:nvSpPr>
-        <p:spPr>
-          <a:xfrm>
-            <a:off x="7772400" y="1783080"/>
-            <a:ext cx="2286000" cy="1097280"/>
-          </a:xfrm>
-          <a:prstGeom prst="rect">
-            <a:avLst/>
-          </a:prstGeom>
-          <a:noFill/>
-        </p:spPr>
-        <p:txBody>
-          <a:bodyPr wrap="square">
-            <a:spAutoFit/>
-          </a:bodyPr>
-          <a:lstStyle/>
-          <a:p>
-            <a:pPr algn="l">
-              <a:spcAft>
-                <a:spcPts val="0"/>
-              </a:spcAft>
-              <a:defRPr sz="1000">
-                <a:solidFill>
-                  <a:srgbClr val="7EC68E"/>
-                </a:solidFill>
-                <a:latin typeface="Calibri"/>
-              </a:defRPr>
-            </a:pPr>
-            <a:r>
-              <a:t>•  supervisor_id</a:t>
-            </a:r>
-          </a:p>
-          <a:p>
-            <a:pPr algn="l">
-              <a:spcAft>
-                <a:spcPts val="0"/>
-              </a:spcAft>
-              <a:defRPr sz="1000">
-                <a:solidFill>
-                  <a:srgbClr val="7EC68E"/>
-                </a:solidFill>
-                <a:latin typeface="Calibri"/>
-              </a:defRPr>
-            </a:pPr>
-            <a:r>
-              <a:t>•  name</a:t>
-            </a:r>
-          </a:p>
-        </p:txBody>
-      </p:sp>
-      <p:sp>
-        <p:nvSpPr>
-          <p:cNvPr id="12" name="Rectangle 11"/>
+          <p:cNvPr id="11" name="Rectangle 10"/>
           <p:cNvSpPr/>
           <p:nvPr/>
         </p:nvSpPr>
@@ -34345,7 +33819,7 @@
       </p:sp>
       <p:sp>
         <p:nvSpPr>
-          <p:cNvPr id="13" name="TextBox 12"/>
+          <p:cNvPr id="12" name="TextBox 11"/>
           <p:cNvSpPr txBox="1"/>
           <p:nvPr/>
         </p:nvSpPr>
@@ -34381,7 +33855,7 @@
       </p:sp>
       <p:sp>
         <p:nvSpPr>
-          <p:cNvPr id="14" name="Rectangle 13"/>
+          <p:cNvPr id="13" name="Rectangle 12"/>
           <p:cNvSpPr/>
           <p:nvPr/>
         </p:nvSpPr>
@@ -34426,7 +33900,7 @@
       </p:sp>
       <p:sp>
         <p:nvSpPr>
-          <p:cNvPr id="15" name="TextBox 14"/>
+          <p:cNvPr id="14" name="TextBox 13"/>
           <p:cNvSpPr txBox="1"/>
           <p:nvPr/>
         </p:nvSpPr>
@@ -34571,14 +34045,14 @@
       </p:sp>
       <p:sp>
         <p:nvSpPr>
-          <p:cNvPr id="16" name="TextBox 15"/>
+          <p:cNvPr id="15" name="TextBox 14"/>
           <p:cNvSpPr txBox="1"/>
           <p:nvPr/>
         </p:nvSpPr>
         <p:spPr>
           <a:xfrm>
             <a:off x="731520" y="5760720"/>
-            <a:ext cx="5029200" cy="365760"/>
+            <a:ext cx="10515600" cy="365760"/>
           </a:xfrm>
           <a:prstGeom prst="rect">
             <a:avLst/>
@@ -34592,7 +34066,7 @@
           <a:lstStyle/>
           <a:p>
             <a:pPr algn="l">
-              <a:defRPr sz="1200" b="0">
+              <a:defRPr sz="1100" b="0">
                 <a:solidFill>
                   <a:srgbClr val="CCCCCC"/>
                 </a:solidFill>
@@ -34600,43 +34074,7 @@
               </a:defRPr>
             </a:pPr>
             <a:r>
-              <a:t>Una persona PUÒ non avere skill, non avere progetti, o non riportare a nessuno.</a:t>
-            </a:r>
-          </a:p>
-        </p:txBody>
-      </p:sp>
-      <p:sp>
-        <p:nvSpPr>
-          <p:cNvPr id="17" name="TextBox 16"/>
-          <p:cNvSpPr txBox="1"/>
-          <p:nvPr/>
-        </p:nvSpPr>
-        <p:spPr>
-          <a:xfrm>
-            <a:off x="5669280" y="5760720"/>
-            <a:ext cx="4846320" cy="365760"/>
-          </a:xfrm>
-          <a:prstGeom prst="rect">
-            <a:avLst/>
-          </a:prstGeom>
-          <a:noFill/>
-        </p:spPr>
-        <p:txBody>
-          <a:bodyPr wrap="square">
-            <a:spAutoFit/>
-          </a:bodyPr>
-          <a:lstStyle/>
-          <a:p>
-            <a:pPr algn="l">
-              <a:defRPr sz="1200" b="0">
-                <a:solidFill>
-                  <a:srgbClr val="F0C040"/>
-                </a:solidFill>
-                <a:latin typeface="Calibri"/>
-              </a:defRPr>
-            </a:pPr>
-            <a:r>
-              <a:t>Tutte le proprietà sono in INGLESE (name, non nome).</a:t>
+              <a:t>Una persona PUÒ non avere skill, non avere progetti, o non riportare a nessuno. Tutte le proprietà sono in INGLESE (name, non nome).</a:t>
             </a:r>
           </a:p>
         </p:txBody>
@@ -35734,7 +35172,7 @@
               </a:defRPr>
             </a:pPr>
             <a:r>
-              <a:t>•    driver = GraphDatabase.driver(URI, auth=(USER, PASS))</a:t>
+              <a:t>  driver = GraphDatabase.driver(URI, auth=(USER, PASS))</a:t>
             </a:r>
           </a:p>
           <a:p>
@@ -35750,7 +35188,7 @@
               </a:defRPr>
             </a:pPr>
             <a:r>
-              <a:t>•    Esegui: MATCH (n) RETURN n LIMIT 25</a:t>
+              <a:t>  Esegui: MATCH (n) RETURN n LIMIT 25</a:t>
             </a:r>
           </a:p>
           <a:p>
@@ -35798,7 +35236,7 @@
               </a:defRPr>
             </a:pPr>
             <a:r>
-              <a:t>•    MATCH (p:Person) WHERE p.location = "Roma"</a:t>
+              <a:t>  MATCH (p:Person) WHERE p.location = "Roma"</a:t>
             </a:r>
           </a:p>
           <a:p>
@@ -35814,7 +35252,7 @@
               </a:defRPr>
             </a:pPr>
             <a:r>
-              <a:t>•    RETURN p.name, p.title</a:t>
+              <a:t>  RETURN p.name, p.title</a:t>
             </a:r>
           </a:p>
           <a:p>
@@ -35862,7 +35300,7 @@
               </a:defRPr>
             </a:pPr>
             <a:r>
-              <a:t>•    MATCH (p:Person) RETURN p.location, count(*)</a:t>
+              <a:t>  MATCH (p:Person) RETURN p.location, count(*)</a:t>
             </a:r>
           </a:p>
           <a:p>
@@ -35878,7 +35316,7 @@
               </a:defRPr>
             </a:pPr>
             <a:r>
-              <a:t>•    ORDER BY count(*) DESC</a:t>
+              <a:t>  ORDER BY count(*) DESC</a:t>
             </a:r>
           </a:p>
           <a:p>
@@ -35926,7 +35364,7 @@
               </a:defRPr>
             </a:pPr>
             <a:r>
-              <a:t>•    MATCH (p:Person {name: 'Mario Rossi'})</a:t>
+              <a:t>  MATCH (p:Person {name: 'Mario Rossi'})</a:t>
             </a:r>
           </a:p>
           <a:p>
@@ -35942,7 +35380,7 @@
               </a:defRPr>
             </a:pPr>
             <a:r>
-              <a:t>•    -[:HAS_SKILL]-&gt;(s:Skill) RETURN s.name</a:t>
+              <a:t>  -[:HAS_SKILL]-&gt;(s:Skill) RETURN s.name</a:t>
             </a:r>
           </a:p>
           <a:p>
@@ -35990,7 +35428,7 @@
               </a:defRPr>
             </a:pPr>
             <a:r>
-              <a:t>•    MATCH (p:Person)-[:HAS_SKILL]-&gt;(s:Skill {name: 'Python'})</a:t>
+              <a:t>  MATCH (p:Person)-[:HAS_SKILL]-&gt;(s:Skill {name: 'Python'})</a:t>
             </a:r>
           </a:p>
           <a:p>
@@ -36006,7 +35444,7 @@
               </a:defRPr>
             </a:pPr>
             <a:r>
-              <a:t>•    RETURN p.name ORDER BY p.name</a:t>
+              <a:t>  RETURN p.name ORDER BY p.name</a:t>
             </a:r>
           </a:p>
         </p:txBody>
@@ -36203,7 +35641,7 @@
               </a:defRPr>
             </a:pPr>
             <a:r>
-              <a:t>•    MATCH (p:Person)-[:HAS_SKILL]-&gt;(s:Skill)</a:t>
+              <a:t>  MATCH (p:Person)-[:HAS_SKILL]-&gt;(s:Skill)</a:t>
             </a:r>
           </a:p>
           <a:p>
@@ -36219,7 +35657,7 @@
               </a:defRPr>
             </a:pPr>
             <a:r>
-              <a:t>•    RETURN s.name, count(*) AS persone</a:t>
+              <a:t>  RETURN s.name, count(*) AS persone</a:t>
             </a:r>
           </a:p>
           <a:p>
@@ -36235,7 +35673,7 @@
               </a:defRPr>
             </a:pPr>
             <a:r>
-              <a:t>•    ORDER BY persone DESC LIMIT 5</a:t>
+              <a:t>  ORDER BY persone DESC LIMIT 5</a:t>
             </a:r>
           </a:p>
           <a:p>
@@ -36283,7 +35721,7 @@
               </a:defRPr>
             </a:pPr>
             <a:r>
-              <a:t>•    MATCH (p:Person)-[h:HAS_SKILL]-&gt;(s:Skill)</a:t>
+              <a:t>  MATCH (p:Person)-[h:HAS_SKILL]-&gt;(s:Skill)</a:t>
             </a:r>
           </a:p>
           <a:p>
@@ -36299,7 +35737,7 @@
               </a:defRPr>
             </a:pPr>
             <a:r>
-              <a:t>•    RETURN s.name, avg(h.proficiency), count(p)</a:t>
+              <a:t>  RETURN s.name, avg(h.proficiency), count(p)</a:t>
             </a:r>
           </a:p>
           <a:p>
@@ -36315,7 +35753,7 @@
               </a:defRPr>
             </a:pPr>
             <a:r>
-              <a:t>•    ORDER BY avg(h.proficiency) DESC LIMIT 10</a:t>
+              <a:t>  ORDER BY avg(h.proficiency) DESC LIMIT 10</a:t>
             </a:r>
           </a:p>
           <a:p>
@@ -36363,7 +35801,7 @@
               </a:defRPr>
             </a:pPr>
             <a:r>
-              <a:t>•    MATCH (p1:Person)-[:WORKED_ON]-&gt;(proj:Project)</a:t>
+              <a:t>  MATCH (p1:Person)-[:WORKED_ON]-&gt;(proj:Project)</a:t>
             </a:r>
           </a:p>
           <a:p>
@@ -36379,7 +35817,7 @@
               </a:defRPr>
             </a:pPr>
             <a:r>
-              <a:t>•      &lt;-[:WORKED_ON]-(p2:Person)</a:t>
+              <a:t>    &lt;-[:WORKED_ON]-(p2:Person)</a:t>
             </a:r>
           </a:p>
           <a:p>
@@ -36395,7 +35833,7 @@
               </a:defRPr>
             </a:pPr>
             <a:r>
-              <a:t>•    RETURN p1.name, p2.name, proj.name LIMIT 10</a:t>
+              <a:t>  RETURN p1.name, p2.name, proj.name LIMIT 10</a:t>
             </a:r>
           </a:p>
           <a:p>
@@ -36443,7 +35881,7 @@
               </a:defRPr>
             </a:pPr>
             <a:r>
-              <a:t>•    MERGE (p:Person {employee_id: 999})</a:t>
+              <a:t>  MERGE (p:Person {employee_id: 999})</a:t>
             </a:r>
           </a:p>
           <a:p>
@@ -36459,7 +35897,7 @@
               </a:defRPr>
             </a:pPr>
             <a:r>
-              <a:t>•    SET p.name = "Test"</a:t>
+              <a:t>  SET p.name = "Test"</a:t>
             </a:r>
           </a:p>
           <a:p>
@@ -36475,7 +35913,7 @@
               </a:defRPr>
             </a:pPr>
             <a:r>
-              <a:t>•    MATCH (s:Skill {name: 'Python'})</a:t>
+              <a:t>  MATCH (s:Skill {name: 'Python'})</a:t>
             </a:r>
           </a:p>
           <a:p>
@@ -36491,7 +35929,7 @@
               </a:defRPr>
             </a:pPr>
             <a:r>
-              <a:t>•    MERGE (p)-[:HAS_SKILL {proficiency: 3}]-&gt;(s)</a:t>
+              <a:t>  MERGE (p)-[:HAS_SKILL {proficiency: 3}]-&gt;(s)</a:t>
             </a:r>
           </a:p>
         </p:txBody>
@@ -39448,7 +38886,7 @@
               </a:defRPr>
             </a:pPr>
             <a:r>
-              <a:t>•    — Mario ha Python con livello 5</a:t>
+              <a:t>  — Mario ha Python con livello 5</a:t>
             </a:r>
           </a:p>
           <a:p>
@@ -39480,7 +38918,7 @@
               </a:defRPr>
             </a:pPr>
             <a:r>
-              <a:t>•    — Mario ha lavorato al progetto AI Platform</a:t>
+              <a:t>  — Mario ha lavorato al progetto AI Platform</a:t>
             </a:r>
           </a:p>
           <a:p>
@@ -39512,7 +38950,7 @@
               </a:defRPr>
             </a:pPr>
             <a:r>
-              <a:t>•    — Mario riporta ad Anna Bianchi</a:t>
+              <a:t>  — Mario riporta ad Anna Bianchi</a:t>
             </a:r>
           </a:p>
         </p:txBody>
@@ -39970,7 +39408,7 @@
         <p:spPr>
           <a:xfrm>
             <a:off x="731520" y="1051560"/>
-            <a:ext cx="5029200" cy="4572000"/>
+            <a:ext cx="5029200" cy="2286000"/>
           </a:xfrm>
           <a:prstGeom prst="rect">
             <a:avLst/>
@@ -40011,7 +39449,7 @@
               </a:defRPr>
             </a:pPr>
             <a:r>
-              <a:t>•    http://localhost:7474 o workspace.neo4j.io</a:t>
+              <a:t>  http://localhost:7474 o workspace.neo4j.io</a:t>
             </a:r>
           </a:p>
           <a:p>
@@ -40027,7 +39465,7 @@
               </a:defRPr>
             </a:pPr>
             <a:r>
-              <a:t>•    • Editor con syntax highlighting</a:t>
+              <a:t>  Editor con syntax highlighting, visualizzazione grafica</a:t>
             </a:r>
           </a:p>
           <a:p>
@@ -40043,7 +39481,7 @@
               </a:defRPr>
             </a:pPr>
             <a:r>
-              <a:t>•    • Visualizzazione grafica dei risultati</a:t>
+              <a:t>  :play movie-graph per tutorial interattivo</a:t>
             </a:r>
           </a:p>
           <a:p>
@@ -40059,7 +39497,7 @@
               </a:defRPr>
             </a:pPr>
             <a:r>
-              <a:t>•    • :play movie-graph per tutorial interattivo</a:t>
+              <a:t>•  Neo4j AuraDB — database cloud managed</a:t>
             </a:r>
           </a:p>
           <a:p>
@@ -40075,7 +39513,7 @@
               </a:defRPr>
             </a:pPr>
             <a:r>
-              <a:t>•  Neo4j AuraDB — cloud managed (Free Tier: 200k nodi)</a:t>
+              <a:t>  Free Tier: 200k nodi, 500k relazioni</a:t>
             </a:r>
           </a:p>
           <a:p>
@@ -40091,7 +39529,7 @@
               </a:defRPr>
             </a:pPr>
             <a:r>
-              <a:t>•    • Zero configurazione, SSL nativo</a:t>
+              <a:t>  Zero configurazione, backup automatici, scaling</a:t>
             </a:r>
           </a:p>
           <a:p>
@@ -40107,7 +39545,7 @@
               </a:defRPr>
             </a:pPr>
             <a:r>
-              <a:t>•    • Backup automatici, scaling a un click</a:t>
+              <a:t>  Usiamo AuraDB per questo corso</a:t>
             </a:r>
           </a:p>
           <a:p>
@@ -40123,7 +39561,7 @@
               </a:defRPr>
             </a:pPr>
             <a:r>
-              <a:t>•    • Usiamo AuraDB per questo corso</a:t>
+              <a:t>•  Neo4j Bloom — visualizzazione senza scrivere Cypher</a:t>
             </a:r>
           </a:p>
           <a:p>
@@ -40139,7 +39577,7 @@
               </a:defRPr>
             </a:pPr>
             <a:r>
-              <a:t>•  Neo4j Bloom — visualizzazione drag &amp; drop senza Cypher</a:t>
+              <a:t>•  Neo4j Desktop — ambiente di sviluppo locale</a:t>
             </a:r>
           </a:p>
           <a:p>
@@ -40155,39 +39593,7 @@
               </a:defRPr>
             </a:pPr>
             <a:r>
-              <a:t>•  Neo4j Workspace — modellazione grafica collaborativa</a:t>
-            </a:r>
-          </a:p>
-          <a:p>
-            <a:pPr algn="l">
-              <a:spcAft>
-                <a:spcPts val="0"/>
-              </a:spcAft>
-              <a:defRPr sz="1200">
-                <a:solidFill>
-                  <a:srgbClr val="FFFFFF"/>
-                </a:solidFill>
-                <a:latin typeface="Calibri"/>
-              </a:defRPr>
-            </a:pPr>
-            <a:r>
-              <a:t>•  Neo4j Desktop — ambiente di sviluppo locale</a:t>
-            </a:r>
-          </a:p>
-          <a:p>
-            <a:pPr algn="l">
-              <a:spcAft>
-                <a:spcPts val="0"/>
-              </a:spcAft>
-              <a:defRPr sz="1200">
-                <a:solidFill>
-                  <a:srgbClr val="FFFFFF"/>
-                </a:solidFill>
-                <a:latin typeface="Calibri"/>
-              </a:defRPr>
-            </a:pPr>
-            <a:r>
-              <a:t>•  Drivers ufficiali: Python, Java, JavaScript, Go, .NET, C</a:t>
+              <a:t>•  Drivers ufficiali: Python, Java, JS, Go, .NET</a:t>
             </a:r>
           </a:p>
         </p:txBody>
@@ -40201,7 +39607,7 @@
         <p:spPr>
           <a:xfrm>
             <a:off x="5669280" y="1051560"/>
-            <a:ext cx="4846320" cy="4572000"/>
+            <a:ext cx="4846320" cy="5029200"/>
           </a:xfrm>
           <a:prstGeom prst="rect">
             <a:avLst/>
@@ -40223,7 +39629,7 @@
               </a:defRPr>
             </a:pPr>
             <a:r>
-              <a:t>Architettura a strati:</a:t>
+              <a:t>Architettura:</a:t>
             </a:r>
             <a:br/>
             <a:br/>
@@ -40273,15 +39679,11 @@
             <a:br/>
             <a:br/>
             <a:r>
-              <a:t>Browser, Bloom e Workspace</a:t>
+              <a:t>Browser, Bloom e Workspace sono</a:t>
             </a:r>
             <a:br/>
             <a:r>
-              <a:t>sono UI che parlano al</a:t>
-            </a:r>
-            <a:br/>
-            <a:r>
-              <a:t>database via Bolt o HTTP.</a:t>
+              <a:t>UI che parlano al database via Bolt.</a:t>
             </a:r>
             <a:br/>
             <a:br/>
@@ -40290,15 +39692,15 @@
             </a:r>
             <a:br/>
             <a:r>
-              <a:t>• Python Driver (codice)</a:t>
+              <a:t>  • Python Driver (codice)</a:t>
             </a:r>
             <a:br/>
             <a:r>
-              <a:t>• Neo4j Browser (esplorazione)</a:t>
+              <a:t>  • Neo4j Browser (esplorazione)</a:t>
             </a:r>
             <a:br/>
             <a:r>
-              <a:t>• AuraDB (cloud)</a:t>
+              <a:t>  • AuraDB (cloud)</a:t>
             </a:r>
           </a:p>
         </p:txBody>

</xml_diff>

<commit_message>
Session 1: resize all code/text boxes to fit content (no overflow)
</commit_message>
<xml_diff>
--- a/slides/session-01/session-01.pptx
+++ b/slides/session-01/session-01.pptx
@@ -24333,7 +24333,7 @@
         <p:spPr>
           <a:xfrm>
             <a:off x="5669280" y="1463040"/>
-            <a:ext cx="4846320" cy="1371600"/>
+            <a:ext cx="4846320" cy="1645920"/>
           </a:xfrm>
           <a:prstGeom prst="rect">
             <a:avLst/>
@@ -24378,7 +24378,7 @@
         <p:spPr>
           <a:xfrm>
             <a:off x="5779008" y="1536192"/>
-            <a:ext cx="4626864" cy="1225296"/>
+            <a:ext cx="4626864" cy="1499616"/>
           </a:xfrm>
           <a:prstGeom prst="rect">
             <a:avLst/>
@@ -24618,7 +24618,7 @@
         <p:spPr>
           <a:xfrm>
             <a:off x="731520" y="3794760"/>
-            <a:ext cx="3657600" cy="2011680"/>
+            <a:ext cx="3657600" cy="2286000"/>
           </a:xfrm>
           <a:prstGeom prst="rect">
             <a:avLst/>
@@ -24699,7 +24699,7 @@
         <p:spPr>
           <a:xfrm>
             <a:off x="4114800" y="3794760"/>
-            <a:ext cx="6400800" cy="2011680"/>
+            <a:ext cx="6400800" cy="2286000"/>
           </a:xfrm>
           <a:prstGeom prst="rect">
             <a:avLst/>
@@ -25699,7 +25699,7 @@
         <p:spPr>
           <a:xfrm>
             <a:off x="731520" y="1463040"/>
-            <a:ext cx="5029200" cy="2011680"/>
+            <a:ext cx="5029200" cy="2194560"/>
           </a:xfrm>
           <a:prstGeom prst="rect">
             <a:avLst/>
@@ -25744,7 +25744,7 @@
         <p:spPr>
           <a:xfrm>
             <a:off x="841248" y="1536192"/>
-            <a:ext cx="4809744" cy="1865376"/>
+            <a:ext cx="4809744" cy="2048256"/>
           </a:xfrm>
           <a:prstGeom prst="rect">
             <a:avLst/>
@@ -25969,7 +25969,7 @@
         <p:spPr>
           <a:xfrm>
             <a:off x="5669280" y="1463040"/>
-            <a:ext cx="4846320" cy="2011680"/>
+            <a:ext cx="4846320" cy="2194560"/>
           </a:xfrm>
           <a:prstGeom prst="rect">
             <a:avLst/>
@@ -26014,7 +26014,7 @@
         <p:spPr>
           <a:xfrm>
             <a:off x="5779008" y="1536192"/>
-            <a:ext cx="4626864" cy="1865376"/>
+            <a:ext cx="4626864" cy="2048256"/>
           </a:xfrm>
           <a:prstGeom prst="rect">
             <a:avLst/>
@@ -26510,7 +26510,7 @@
         <p:spPr>
           <a:xfrm>
             <a:off x="731520" y="1828800"/>
-            <a:ext cx="5029200" cy="1645920"/>
+            <a:ext cx="5029200" cy="1920240"/>
           </a:xfrm>
           <a:prstGeom prst="rect">
             <a:avLst/>
@@ -26555,7 +26555,7 @@
         <p:spPr>
           <a:xfrm>
             <a:off x="841248" y="1901952"/>
-            <a:ext cx="4809744" cy="1499616"/>
+            <a:ext cx="4809744" cy="1773936"/>
           </a:xfrm>
           <a:prstGeom prst="rect">
             <a:avLst/>
@@ -26787,7 +26787,7 @@
         <p:spPr>
           <a:xfrm>
             <a:off x="5669280" y="1828800"/>
-            <a:ext cx="4846320" cy="1645920"/>
+            <a:ext cx="4846320" cy="2103120"/>
           </a:xfrm>
           <a:prstGeom prst="rect">
             <a:avLst/>
@@ -26832,7 +26832,7 @@
         <p:spPr>
           <a:xfrm>
             <a:off x="5779008" y="1901952"/>
-            <a:ext cx="4626864" cy="1499616"/>
+            <a:ext cx="4626864" cy="1956816"/>
           </a:xfrm>
           <a:prstGeom prst="rect">
             <a:avLst/>
@@ -27043,7 +27043,7 @@
         </p:nvSpPr>
         <p:spPr>
           <a:xfrm>
-            <a:off x="731520" y="3840480"/>
+            <a:off x="731520" y="4206240"/>
             <a:ext cx="10698480" cy="36576"/>
           </a:xfrm>
           <a:prstGeom prst="rect">
@@ -27086,7 +27086,7 @@
         </p:nvSpPr>
         <p:spPr>
           <a:xfrm>
-            <a:off x="731520" y="4023360"/>
+            <a:off x="731520" y="4389120"/>
             <a:ext cx="10515600" cy="365760"/>
           </a:xfrm>
           <a:prstGeom prst="rect">
@@ -27122,7 +27122,7 @@
         </p:nvSpPr>
         <p:spPr>
           <a:xfrm>
-            <a:off x="731520" y="4434840"/>
+            <a:off x="731520" y="4800600"/>
             <a:ext cx="10515600" cy="1645920"/>
           </a:xfrm>
           <a:prstGeom prst="rect">
@@ -27167,7 +27167,7 @@
         </p:nvSpPr>
         <p:spPr>
           <a:xfrm>
-            <a:off x="841248" y="4507992"/>
+            <a:off x="841248" y="4873752"/>
             <a:ext cx="10296144" cy="1499616"/>
           </a:xfrm>
           <a:prstGeom prst="rect">
@@ -28059,7 +28059,7 @@
         <p:spPr>
           <a:xfrm>
             <a:off x="731520" y="4206240"/>
-            <a:ext cx="5029200" cy="1645920"/>
+            <a:ext cx="5029200" cy="1828800"/>
           </a:xfrm>
           <a:prstGeom prst="rect">
             <a:avLst/>
@@ -28104,7 +28104,7 @@
         <p:spPr>
           <a:xfrm>
             <a:off x="841248" y="4279392"/>
-            <a:ext cx="4809744" cy="1499616"/>
+            <a:ext cx="4809744" cy="1682496"/>
           </a:xfrm>
           <a:prstGeom prst="rect">
             <a:avLst/>
@@ -28836,7 +28836,7 @@
         <p:spPr>
           <a:xfrm>
             <a:off x="5669280" y="1371600"/>
-            <a:ext cx="4846320" cy="1828800"/>
+            <a:ext cx="4846320" cy="2011680"/>
           </a:xfrm>
           <a:prstGeom prst="rect">
             <a:avLst/>
@@ -28881,7 +28881,7 @@
         <p:spPr>
           <a:xfrm>
             <a:off x="5779008" y="1444752"/>
-            <a:ext cx="4626864" cy="1682496"/>
+            <a:ext cx="4626864" cy="1865376"/>
           </a:xfrm>
           <a:prstGeom prst="rect">
             <a:avLst/>
@@ -29637,7 +29637,7 @@
         <p:spPr>
           <a:xfrm>
             <a:off x="5669280" y="1463040"/>
-            <a:ext cx="4846320" cy="1828800"/>
+            <a:ext cx="4846320" cy="2011680"/>
           </a:xfrm>
           <a:prstGeom prst="rect">
             <a:avLst/>
@@ -29682,7 +29682,7 @@
         <p:spPr>
           <a:xfrm>
             <a:off x="5779008" y="1536192"/>
-            <a:ext cx="4626864" cy="1682496"/>
+            <a:ext cx="4626864" cy="1865376"/>
           </a:xfrm>
           <a:prstGeom prst="rect">
             <a:avLst/>
@@ -29967,7 +29967,7 @@
         <p:spPr>
           <a:xfrm>
             <a:off x="731520" y="4297680"/>
-            <a:ext cx="5029200" cy="1645920"/>
+            <a:ext cx="5029200" cy="1828800"/>
           </a:xfrm>
           <a:prstGeom prst="rect">
             <a:avLst/>
@@ -30012,7 +30012,7 @@
         <p:spPr>
           <a:xfrm>
             <a:off x="841248" y="4370832"/>
-            <a:ext cx="4809744" cy="1499616"/>
+            <a:ext cx="4809744" cy="1682496"/>
           </a:xfrm>
           <a:prstGeom prst="rect">
             <a:avLst/>
@@ -30192,7 +30192,7 @@
         <p:spPr>
           <a:xfrm>
             <a:off x="5669280" y="4297680"/>
-            <a:ext cx="4846320" cy="1920240"/>
+            <a:ext cx="4846320" cy="2103120"/>
           </a:xfrm>
           <a:prstGeom prst="rect">
             <a:avLst/>
@@ -30237,7 +30237,7 @@
         <p:spPr>
           <a:xfrm>
             <a:off x="5779008" y="4370832"/>
-            <a:ext cx="4626864" cy="1773936"/>
+            <a:ext cx="4626864" cy="1956816"/>
           </a:xfrm>
           <a:prstGeom prst="rect">
             <a:avLst/>
@@ -31161,7 +31161,7 @@
         <p:spPr>
           <a:xfrm>
             <a:off x="731520" y="1051560"/>
-            <a:ext cx="5029200" cy="1828800"/>
+            <a:ext cx="5029200" cy="2286000"/>
           </a:xfrm>
           <a:prstGeom prst="rect">
             <a:avLst/>
@@ -31348,7 +31348,7 @@
         <p:spPr>
           <a:xfrm>
             <a:off x="5669280" y="1508760"/>
-            <a:ext cx="4846320" cy="1828800"/>
+            <a:ext cx="4846320" cy="2194560"/>
           </a:xfrm>
           <a:prstGeom prst="rect">
             <a:avLst/>
@@ -31457,7 +31457,7 @@
         <p:spPr>
           <a:xfrm>
             <a:off x="731520" y="3566160"/>
-            <a:ext cx="5029200" cy="2286000"/>
+            <a:ext cx="5029200" cy="2560320"/>
           </a:xfrm>
           <a:prstGeom prst="rect">
             <a:avLst/>
@@ -31502,7 +31502,7 @@
         <p:spPr>
           <a:xfrm>
             <a:off x="841248" y="3639312"/>
-            <a:ext cx="4809744" cy="2139696"/>
+            <a:ext cx="4809744" cy="2414016"/>
           </a:xfrm>
           <a:prstGeom prst="rect">
             <a:avLst/>
@@ -32272,7 +32272,7 @@
         <p:spPr>
           <a:xfrm>
             <a:off x="731520" y="2560320"/>
-            <a:ext cx="5029200" cy="2743200"/>
+            <a:ext cx="5029200" cy="3017520"/>
           </a:xfrm>
           <a:prstGeom prst="rect">
             <a:avLst/>
@@ -32317,7 +32317,7 @@
         <p:spPr>
           <a:xfrm>
             <a:off x="841248" y="2633472"/>
-            <a:ext cx="4809744" cy="2596896"/>
+            <a:ext cx="4809744" cy="2871216"/>
           </a:xfrm>
           <a:prstGeom prst="rect">
             <a:avLst/>
@@ -32606,7 +32606,7 @@
         <p:spPr>
           <a:xfrm>
             <a:off x="5669280" y="2560320"/>
-            <a:ext cx="4846320" cy="2743200"/>
+            <a:ext cx="4846320" cy="3017520"/>
           </a:xfrm>
           <a:prstGeom prst="rect">
             <a:avLst/>
@@ -32651,7 +32651,7 @@
         <p:spPr>
           <a:xfrm>
             <a:off x="5779008" y="2633472"/>
-            <a:ext cx="4626864" cy="2596896"/>
+            <a:ext cx="4626864" cy="2871216"/>
           </a:xfrm>
           <a:prstGeom prst="rect">
             <a:avLst/>
@@ -32917,7 +32917,7 @@
         </p:nvSpPr>
         <p:spPr>
           <a:xfrm>
-            <a:off x="731520" y="5486400"/>
+            <a:off x="731520" y="5760720"/>
             <a:ext cx="10698480" cy="36576"/>
           </a:xfrm>
           <a:prstGeom prst="rect">
@@ -32960,7 +32960,7 @@
         </p:nvSpPr>
         <p:spPr>
           <a:xfrm>
-            <a:off x="731520" y="5669280"/>
+            <a:off x="731520" y="5943600"/>
             <a:ext cx="10515600" cy="365760"/>
           </a:xfrm>
           <a:prstGeom prst="rect">
@@ -33278,7 +33278,7 @@
         <p:spPr>
           <a:xfrm>
             <a:off x="5669280" y="1463040"/>
-            <a:ext cx="4846320" cy="2011680"/>
+            <a:ext cx="4846320" cy="2377440"/>
           </a:xfrm>
           <a:prstGeom prst="rect">
             <a:avLst/>
@@ -33366,8 +33366,8 @@
         </p:nvSpPr>
         <p:spPr>
           <a:xfrm>
-            <a:off x="5669280" y="3657600"/>
-            <a:ext cx="4846320" cy="1097280"/>
+            <a:off x="5669280" y="3931920"/>
+            <a:ext cx="4846320" cy="1645920"/>
           </a:xfrm>
           <a:prstGeom prst="rect">
             <a:avLst/>
@@ -34349,7 +34349,7 @@
               </a:defRPr>
             </a:pPr>
             <a:r>
-              <a:t>// Output:</a:t>
+              <a:t>// Co-protagonisti di Tom Hanks:</a:t>
             </a:r>
           </a:p>
           <a:p>
@@ -34365,7 +34365,7 @@
               </a:defRPr>
             </a:pPr>
             <a:r>
-              <a:t>// Tom Hanks | Cloud Atlas | 2012</a:t>
+              <a:t>MATCH (tom:Person {name: "Tom Hanks"})</a:t>
             </a:r>
           </a:p>
           <a:p>
@@ -34381,7 +34381,7 @@
               </a:defRPr>
             </a:pPr>
             <a:r>
-              <a:t>// Hugo Weaving | Cloud Atlas | 2012</a:t>
+              <a:t>  -[:ACTED_IN]-&gt;(m:Movie)&lt;-[:ACTED_IN]-(co:Person)</a:t>
             </a:r>
           </a:p>
           <a:p>
@@ -34396,6 +34396,9 @@
                 <a:latin typeface="Consolas"/>
               </a:defRPr>
             </a:pPr>
+            <a:r>
+              <a:t>RETURN co.name, m.title ORDER BY m.title;</a:t>
+            </a:r>
           </a:p>
           <a:p>
             <a:pPr>
@@ -34409,9 +34412,6 @@
                 <a:latin typeface="Consolas"/>
               </a:defRPr>
             </a:pPr>
-            <a:r>
-              <a:t>// Co-protagonisti di Tom Hanks:</a:t>
-            </a:r>
           </a:p>
           <a:p>
             <a:pPr>
@@ -34426,7 +34426,7 @@
               </a:defRPr>
             </a:pPr>
             <a:r>
-              <a:t>MATCH (tom:Person {name: "Tom Hanks"})</a:t>
+              <a:t>// Output: Meg Ryan | Sleepless in Seattle</a:t>
             </a:r>
           </a:p>
           <a:p>
@@ -34442,100 +34442,7 @@
               </a:defRPr>
             </a:pPr>
             <a:r>
-              <a:t>  -[:ACTED_IN]-&gt;(m:Movie)&lt;-[:ACTED_IN]-(co:Person)</a:t>
-            </a:r>
-          </a:p>
-          <a:p>
-            <a:pPr>
-              <a:spcAft>
-                <a:spcPts val="100"/>
-              </a:spcAft>
-              <a:defRPr sz="1000">
-                <a:solidFill>
-                  <a:srgbClr val="7EC68E"/>
-                </a:solidFill>
-                <a:latin typeface="Consolas"/>
-              </a:defRPr>
-            </a:pPr>
-            <a:r>
-              <a:t>RETURN co.name, m.title ORDER BY m.title;</a:t>
-            </a:r>
-          </a:p>
-          <a:p>
-            <a:pPr>
-              <a:spcAft>
-                <a:spcPts val="100"/>
-              </a:spcAft>
-              <a:defRPr sz="1000">
-                <a:solidFill>
-                  <a:srgbClr val="7EC68E"/>
-                </a:solidFill>
-                <a:latin typeface="Consolas"/>
-              </a:defRPr>
-            </a:pPr>
-          </a:p>
-          <a:p>
-            <a:pPr>
-              <a:spcAft>
-                <a:spcPts val="100"/>
-              </a:spcAft>
-              <a:defRPr sz="1000">
-                <a:solidFill>
-                  <a:srgbClr val="7EC68E"/>
-                </a:solidFill>
-                <a:latin typeface="Consolas"/>
-              </a:defRPr>
-            </a:pPr>
-            <a:r>
-              <a:t>// Output:</a:t>
-            </a:r>
-          </a:p>
-          <a:p>
-            <a:pPr>
-              <a:spcAft>
-                <a:spcPts val="100"/>
-              </a:spcAft>
-              <a:defRPr sz="1000">
-                <a:solidFill>
-                  <a:srgbClr val="7EC68E"/>
-                </a:solidFill>
-                <a:latin typeface="Consolas"/>
-              </a:defRPr>
-            </a:pPr>
-            <a:r>
-              <a:t>// Meg Ryan | Sleepless in Seattle</a:t>
-            </a:r>
-          </a:p>
-          <a:p>
-            <a:pPr>
-              <a:spcAft>
-                <a:spcPts val="100"/>
-              </a:spcAft>
-              <a:defRPr sz="1000">
-                <a:solidFill>
-                  <a:srgbClr val="7EC68E"/>
-                </a:solidFill>
-                <a:latin typeface="Consolas"/>
-              </a:defRPr>
-            </a:pPr>
-            <a:r>
-              <a:t>// Meg Ryan | You've Got Mail</a:t>
-            </a:r>
-          </a:p>
-          <a:p>
-            <a:pPr>
-              <a:spcAft>
-                <a:spcPts val="100"/>
-              </a:spcAft>
-              <a:defRPr sz="1000">
-                <a:solidFill>
-                  <a:srgbClr val="7EC68E"/>
-                </a:solidFill>
-                <a:latin typeface="Consolas"/>
-              </a:defRPr>
-            </a:pPr>
-            <a:r>
-              <a:t>// Bill Paxton | Apollo 13</a:t>
+              <a:t>//         Bill Paxton | Apollo 13</a:t>
             </a:r>
           </a:p>
         </p:txBody>
@@ -34549,7 +34456,7 @@
         <p:spPr>
           <a:xfrm>
             <a:off x="5669280" y="1371600"/>
-            <a:ext cx="4846320" cy="2560320"/>
+            <a:ext cx="4846320" cy="2651760"/>
           </a:xfrm>
           <a:prstGeom prst="rect">
             <a:avLst/>
@@ -34594,7 +34501,7 @@
         <p:spPr>
           <a:xfrm>
             <a:off x="5779008" y="1444752"/>
-            <a:ext cx="4626864" cy="2414016"/>
+            <a:ext cx="4626864" cy="2505456"/>
           </a:xfrm>
           <a:prstGeom prst="rect">
             <a:avLst/>
@@ -34696,67 +34603,6 @@
               </a:defRPr>
             </a:pPr>
             <a:r>
-              <a:t>// Output:</a:t>
-            </a:r>
-          </a:p>
-          <a:p>
-            <a:pPr>
-              <a:spcAft>
-                <a:spcPts val="100"/>
-              </a:spcAft>
-              <a:defRPr sz="1000">
-                <a:solidFill>
-                  <a:srgbClr val="7EC68E"/>
-                </a:solidFill>
-                <a:latin typeface="Consolas"/>
-              </a:defRPr>
-            </a:pPr>
-            <a:r>
-              <a:t>// Tom Hanks | 12</a:t>
-            </a:r>
-          </a:p>
-          <a:p>
-            <a:pPr>
-              <a:spcAft>
-                <a:spcPts val="100"/>
-              </a:spcAft>
-              <a:defRPr sz="1000">
-                <a:solidFill>
-                  <a:srgbClr val="7EC68E"/>
-                </a:solidFill>
-                <a:latin typeface="Consolas"/>
-              </a:defRPr>
-            </a:pPr>
-            <a:r>
-              <a:t>// Keanu Reeves | 10</a:t>
-            </a:r>
-          </a:p>
-          <a:p>
-            <a:pPr>
-              <a:spcAft>
-                <a:spcPts val="100"/>
-              </a:spcAft>
-              <a:defRPr sz="1000">
-                <a:solidFill>
-                  <a:srgbClr val="7EC68E"/>
-                </a:solidFill>
-                <a:latin typeface="Consolas"/>
-              </a:defRPr>
-            </a:pPr>
-          </a:p>
-          <a:p>
-            <a:pPr>
-              <a:spcAft>
-                <a:spcPts val="100"/>
-              </a:spcAft>
-              <a:defRPr sz="1000">
-                <a:solidFill>
-                  <a:srgbClr val="7EC68E"/>
-                </a:solidFill>
-                <a:latin typeface="Consolas"/>
-              </a:defRPr>
-            </a:pPr>
-            <a:r>
               <a:t>// Registi e i loro attori:</a:t>
             </a:r>
           </a:p>
@@ -34866,7 +34712,7 @@
         </p:nvSpPr>
         <p:spPr>
           <a:xfrm>
-            <a:off x="731520" y="3931920"/>
+            <a:off x="731520" y="4023360"/>
             <a:ext cx="10698480" cy="36576"/>
           </a:xfrm>
           <a:prstGeom prst="rect">
@@ -34909,7 +34755,7 @@
         </p:nvSpPr>
         <p:spPr>
           <a:xfrm>
-            <a:off x="731520" y="4114800"/>
+            <a:off x="731520" y="4206240"/>
             <a:ext cx="10515600" cy="365760"/>
           </a:xfrm>
           <a:prstGeom prst="rect">
@@ -34945,7 +34791,7 @@
         </p:nvSpPr>
         <p:spPr>
           <a:xfrm>
-            <a:off x="731520" y="4572000"/>
+            <a:off x="731520" y="4663440"/>
             <a:ext cx="10515600" cy="1371600"/>
           </a:xfrm>
           <a:prstGeom prst="rect">

</xml_diff>